<commit_message>
Correct the question count after the duplicate removal
Removing nine duplicated questions took the bank from 1,260 to 1,251, but the
deck, the ERD diagram and the speaker script were regenerated before that
change and still quoted the old number. It appears in the summary slide, the
narration, the ERD subject-area caption and the delivery-notes crib sheet, so
whoever presents would have said a number that does not match the database
they are about to open on camera.
</commit_message>
<xml_diff>
--- a/presentation/JobHopper_Final_Presentation.pptx
+++ b/presentation/JobHopper_Final_Presentation.pptx
@@ -1321,7 +1321,7 @@
           </a:p>
           <a:p>
             <a:r>
-              <a:t>so 1,260 questions. And 250 tests on every pull request.</a:t>
+              <a:t>so more than 1,250 questions. And 250 tests on every pull request.</a:t>
             </a:r>
           </a:p>
           <a:p/>
@@ -9045,7 +9045,7 @@
                 </a:solidFill>
                 <a:latin typeface="Calibri"/>
               </a:rPr>
-              <a:t>▸ The question bank beat its target: 15 per skill per difficulty,</a:t>
+              <a:t>▸ The question bank beat its target: about 15 per skill per</a:t>
             </a:r>
           </a:p>
           <a:p>
@@ -9064,7 +9064,7 @@
                 </a:solidFill>
                 <a:latin typeface="Calibri"/>
               </a:rPr>
-              <a:t>which is 1,260 questions across 28 skills.</a:t>
+              <a:t>difficulty, which is 1,251 questions across 28 skills.</a:t>
             </a:r>
           </a:p>
           <a:p>

</xml_diff>